<commit_message>
Add baseline benchmark, DA-MFS optimisation, master context, and updated reports
Baseline: five ensemble models (RF, ExtraTrees, HistGB, XGBoost, soft-voting) trained on
the full datasets; same-dataset 0.96-0.97 but cross-dataset only 0.37-0.42 (balanced accuracy
0.46-0.49, near random), reproducing the generalisation gap.

DA-MFS (main contribution): domain alignment (per-dataset quantile transform) + GA/PSO
feature selection with a cross-dataset fitness. Improves cross-dataset accuracy 0.373 -> 0.508
(+13.6pp), balanced accuracy +10.4pp, macro-F1 +15.3pp, attack recall +12.8pp using 4 features.

Adds scripts (baseline_cross_dataset, aggregate_baseline, baseline_figures, metaheuristic_fs,
domain_aligned_fs, da_mfs_tables), results, figures, and MASTER_CONTEXT (md/txt/pdf).
Updates report (19pp), presentation (21 slides), explainer, and viva Q&A.
</commit_message>
<xml_diff>
--- a/reports/06_presentation.pptx
+++ b/reports/06_presentation.pptx
@@ -25,6 +25,7 @@
     <p:sldId id="273" r:id="rId19"/>
     <p:sldId id="274" r:id="rId20"/>
     <p:sldId id="275" r:id="rId21"/>
+    <p:sldId id="276" r:id="rId22"/>
   </p:sldIdLst>
   <p:sldSz cx="9144000" cy="5143500" type="screen16x9"/>
   <p:notesSz cx="6858000" cy="9144000"/>
@@ -3166,6 +3167,12 @@
               <a:rPr/>
               <a:t>B.Tech. Project – I | Mid-Semester Evaluation</a:t>
             </a:r>
+            <a:br/>
+            <a:br/>
+            <a:r>
+              <a:rPr/>
+              <a:t>Shivam Chauhan (2023UIN3323) · Shantanu Agarwal (2023UIN3330) · Deepesh (2023UIN3358) — Supervisor: Dr. Preeti Bansal | Dept. of Information Technology, NSUT</a:t>
+            </a:r>
           </a:p>
         </p:txBody>
       </p:sp>
@@ -5475,81 +5482,59 @@
             <a:pPr lvl="0"/>
             <a:r>
               <a:rPr/>
-              <a:t>All three datasets downloaded and inspected.</a:t>
+              <a:t>All three datasets downloaded and analysed; figures generated automatically.</a:t>
             </a:r>
           </a:p>
           <a:p>
             <a:pPr lvl="0"/>
             <a:r>
-              <a:rPr/>
-              <a:t>Automated </a:t>
-            </a:r>
-            <a:r>
               <a:rPr b="1"/>
-              <a:t>dataset-analysis pipeline</a:t>
-            </a:r>
-            <a:r>
-              <a:rPr/>
-              <a:t> (rows, class distributions, NaN/Inf counts).</a:t>
+              <a:t>Shared 12-feature subspace implemented</a:t>
+            </a:r>
+            <a:r>
+              <a:rPr/>
+              <a:t> (identity/leakage features removed).</a:t>
             </a:r>
           </a:p>
           <a:p>
             <a:pPr lvl="0"/>
             <a:r>
-              <a:rPr/>
-              <a:t>Automated </a:t>
-            </a:r>
-            <a:r>
               <a:rPr b="1"/>
-              <a:t>figure-generation pipeline</a:t>
-            </a:r>
-            <a:r>
-              <a:rPr/>
-              <a:t> for all report charts.</a:t>
+              <a:t>Cross-dataset baseline benchmark: 5 ensemble models trained on the full datasets</a:t>
+            </a:r>
+            <a:r>
+              <a:rPr/>
+              <a:t>, evaluated on all pairs → 3×3 matrices.</a:t>
+            </a:r>
+          </a:p>
+          <a:p>
+            <a:pPr lvl="0" indent="0" marL="0">
+              <a:buNone/>
+            </a:pPr>
+            <a:r>
+              <a:rPr b="1"/>
+              <a:t>Next (end-semester)</a:t>
             </a:r>
           </a:p>
           <a:p>
             <a:pPr lvl="0"/>
             <a:r>
               <a:rPr/>
-              <a:t>Feature-harmonisation mapping and label taxonomy specified.</a:t>
+              <a:t>GA / PSO / DE optimisers with the cross-dataset fitness function.</a:t>
             </a:r>
           </a:p>
           <a:p>
             <a:pPr lvl="0"/>
             <a:r>
               <a:rPr/>
-              <a:t>Cleaning rules for Inf/NaN, duplicated column, label-encoding artefact, identity features.</a:t>
-            </a:r>
-          </a:p>
-          <a:p>
-            <a:pPr lvl="0" indent="0" marL="0">
-              <a:buNone/>
-            </a:pPr>
-            <a:r>
-              <a:rPr b="1"/>
-              <a:t>In progress / next</a:t>
+              <a:t>Standard feature-selection baselines (MI, RF-importance, PCA, RFE, LASSO).</a:t>
             </a:r>
           </a:p>
           <a:p>
             <a:pPr lvl="0"/>
             <a:r>
               <a:rPr/>
-              <a:t>Cleaning &amp; harmonisation code; cached harmonised matrices.</a:t>
-            </a:r>
-          </a:p>
-          <a:p>
-            <a:pPr lvl="0"/>
-            <a:r>
-              <a:rPr/>
-              <a:t>Cross-dataset model benchmark.</a:t>
-            </a:r>
-          </a:p>
-          <a:p>
-            <a:pPr lvl="0"/>
-            <a:r>
-              <a:rPr/>
-              <a:t>GA/PSO/DE optimisers + baseline feature selectors.</a:t>
+              <a:t>Transfer analysis (SHAP/UMAP, ablations) and practical guidelines.</a:t>
             </a:r>
           </a:p>
         </p:txBody>
@@ -5586,7 +5571,12 @@
             <p:ph type="title"/>
           </p:nvPr>
         </p:nvSpPr>
-        <p:spPr/>
+        <p:spPr>
+          <a:xfrm>
+            <a:off x="457201" y="204787"/>
+            <a:ext cx="3008313" cy="871538"/>
+          </a:xfrm>
+        </p:spPr>
         <p:txBody>
           <a:bodyPr/>
           <a:lstStyle/>
@@ -5596,19 +5586,19 @@
             </a:pPr>
             <a:r>
               <a:rPr/>
-              <a:t>Results &amp; Discussion (dataset analysis)</a:t>
-            </a:r>
-          </a:p>
-        </p:txBody>
-      </p:sp>
-      <p:sp>
-        <p:nvSpPr>
-          <p:cNvPr id="3" name="Content Placeholder 2"/>
-          <p:cNvSpPr>
-            <a:spLocks noGrp="1"/>
-          </p:cNvSpPr>
-          <p:nvPr>
-            <p:ph idx="1"/>
+              <a:t>Baseline Cross-Dataset Results</a:t>
+            </a:r>
+          </a:p>
+        </p:txBody>
+      </p:sp>
+      <p:sp>
+        <p:nvSpPr>
+          <p:cNvPr id="4" name="Text Placeholder 3"/>
+          <p:cNvSpPr>
+            <a:spLocks noGrp="1"/>
+          </p:cNvSpPr>
+          <p:nvPr>
+            <p:ph idx="2" sz="half" type="body"/>
           </p:nvPr>
         </p:nvSpPr>
         <p:spPr/>
@@ -5616,98 +5606,118 @@
           <a:bodyPr/>
           <a:lstStyle/>
           <a:p>
-            <a:pPr lvl="0" indent="0" marL="0">
+            <a:pPr lvl="0"/>
+            <a:r>
+              <a:rPr/>
+              <a:t>Trained </a:t>
+            </a:r>
+            <a:r>
+              <a:rPr b="1"/>
+              <a:t>5 ensemble models on the full datasets</a:t>
+            </a:r>
+            <a:r>
+              <a:rPr/>
+              <a:t>; tested on all three (3×3 matrix).</a:t>
+            </a:r>
+          </a:p>
+          <a:p>
+            <a:pPr lvl="0"/>
+            <a:r>
+              <a:rPr/>
+              <a:t>Same-dataset accuracy </a:t>
+            </a:r>
+            <a:r>
+              <a:rPr b="1"/>
+              <a:t>0.96–0.97</a:t>
+            </a:r>
+            <a:r>
+              <a:rPr/>
+              <a:t>; cross-dataset only </a:t>
+            </a:r>
+            <a:r>
+              <a:rPr b="1"/>
+              <a:t>0.37–0.42</a:t>
+            </a:r>
+            <a:r>
+              <a:rPr/>
+              <a:t>.</a:t>
+            </a:r>
+          </a:p>
+          <a:p>
+            <a:pPr lvl="0"/>
+            <a:r>
+              <a:rPr/>
+              <a:t>Cross-dataset </a:t>
+            </a:r>
+            <a:r>
+              <a:rPr b="1"/>
+              <a:t>balanced accuracy 0.46–0.49 → at/near random chance (0.50)</a:t>
+            </a:r>
+            <a:r>
+              <a:rPr/>
+              <a:t>.</a:t>
+            </a:r>
+          </a:p>
+        </p:txBody>
+      </p:sp>
+      <p:pic>
+        <p:nvPicPr>
+          <p:cNvPr descr="figures/fig_baseline_same_vs_cross.png" id="0" name="Picture 1"/>
+          <p:cNvPicPr>
+            <a:picLocks noGrp="1" noChangeAspect="1"/>
+          </p:cNvPicPr>
+          <p:nvPr/>
+        </p:nvPicPr>
+        <p:blipFill>
+          <a:blip r:embed="rId2"/>
+          <a:stretch>
+            <a:fillRect/>
+          </a:stretch>
+        </p:blipFill>
+        <p:spPr bwMode="auto">
+          <a:xfrm>
+            <a:off x="3568700" y="1168400"/>
+            <a:ext cx="5105400" cy="1943100"/>
+          </a:xfrm>
+          <a:prstGeom prst="rect">
+            <a:avLst/>
+          </a:prstGeom>
+          <a:noFill/>
+          <a:ln w="9525">
+            <a:noFill/>
+            <a:headEnd/>
+            <a:tailEnd/>
+          </a:ln>
+        </p:spPr>
+      </p:pic>
+      <p:sp>
+        <p:nvSpPr>
+          <p:cNvPr id="1" name="TextBox 3"/>
+          <p:cNvSpPr txBox="1"/>
+          <p:nvPr>
+            <p:ph idx="1"/>
+          </p:nvPr>
+        </p:nvSpPr>
+        <p:spPr>
+          <a:xfrm>
+            <a:off x="3568700" y="4076700"/>
+            <a:ext cx="5105400" cy="508000"/>
+          </a:xfrm>
+          <a:prstGeom prst="rect">
+            <a:avLst/>
+          </a:prstGeom>
+          <a:noFill/>
+        </p:spPr>
+        <p:txBody>
+          <a:bodyPr/>
+          <a:lstStyle/>
+          <a:p>
+            <a:pPr lvl="0" indent="0" marL="0" algn="ctr">
               <a:buNone/>
             </a:pPr>
             <a:r>
-              <a:rPr b="1"/>
-              <a:t>Measured findings so far</a:t>
-            </a:r>
-          </a:p>
-          <a:p>
-            <a:pPr lvl="0"/>
-            <a:r>
-              <a:rPr/>
-              <a:t>CIC-IDS-2017: 2,830,743 flows, </a:t>
-            </a:r>
-            <a:r>
-              <a:rPr b="1"/>
-              <a:t>80.3% benign</a:t>
-            </a:r>
-            <a:r>
-              <a:rPr/>
-              <a:t>, 4,376 Inf + 1,358 NaN cells, one duplicated column.</a:t>
-            </a:r>
-          </a:p>
-          <a:p>
-            <a:pPr lvl="0"/>
-            <a:r>
-              <a:rPr/>
-              <a:t>UNSW-NB15: 257,673 records, 9 attack classes + Normal.</a:t>
-            </a:r>
-          </a:p>
-          <a:p>
-            <a:pPr lvl="0"/>
-            <a:r>
-              <a:rPr/>
-              <a:t>TON_IoT: 211,043 records, </a:t>
-            </a:r>
-            <a:r>
-              <a:rPr b="1"/>
-              <a:t>near-balanced</a:t>
-            </a:r>
-            <a:r>
-              <a:rPr/>
-              <a:t> attack classes (20,000 each, except MITM 1,043).</a:t>
-            </a:r>
-          </a:p>
-          <a:p>
-            <a:pPr lvl="0"/>
-            <a:r>
-              <a:rPr b="1"/>
-              <a:t>Schema mismatch:</a:t>
-            </a:r>
-            <a:r>
-              <a:rPr/>
-              <a:t> no shared column names; only ~6 raw features semantically common.</a:t>
-            </a:r>
-          </a:p>
-          <a:p>
-            <a:pPr lvl="0" indent="0" marL="0">
-              <a:buNone/>
-            </a:pPr>
-            <a:r>
-              <a:rPr b="1"/>
-              <a:t>Discussion</a:t>
-            </a:r>
-          </a:p>
-          <a:p>
-            <a:pPr lvl="0"/>
-            <a:r>
-              <a:rPr b="1"/>
-              <a:t>Overall accuracy is misleading</a:t>
-            </a:r>
-            <a:r>
-              <a:rPr/>
-              <a:t> → we use balanced accuracy and macro-F1.</a:t>
-            </a:r>
-          </a:p>
-          <a:p>
-            <a:pPr lvl="0"/>
-            <a:r>
-              <a:rPr b="1"/>
-              <a:t>Identity/port features inflate same-dataset scores</a:t>
-            </a:r>
-            <a:r>
-              <a:rPr/>
-              <a:t> and destroy transfer [1], [3].</a:t>
-            </a:r>
-          </a:p>
-          <a:p>
-            <a:pPr lvl="0"/>
-            <a:r>
-              <a:rPr/>
-              <a:t>Baseline model benchmarking (expected: high same-dataset, near-chance cross-dataset) is the next step.</a:t>
+              <a:rPr/>
+              <a:t>Same-dataset vs cross-dataset</a:t>
             </a:r>
           </a:p>
         </p:txBody>
@@ -5718,6 +5728,1086 @@
 </file>
 
 <file path=ppt/slides/slide17.xml><?xml version="1.0" encoding="utf-8"?>
+<p:sld xmlns:a="http://schemas.openxmlformats.org/drawingml/2006/main" xmlns:r="http://schemas.openxmlformats.org/officeDocument/2006/relationships" xmlns:p="http://schemas.openxmlformats.org/presentationml/2006/main">
+  <p:cSld>
+    <p:spTree>
+      <p:nvGrpSpPr>
+        <p:cNvPr id="1" name=""/>
+        <p:cNvGrpSpPr/>
+        <p:nvPr/>
+      </p:nvGrpSpPr>
+      <p:grpSpPr>
+        <a:xfrm>
+          <a:off x="0" y="0"/>
+          <a:ext cx="0" cy="0"/>
+          <a:chOff x="0" y="0"/>
+          <a:chExt cx="0" cy="0"/>
+        </a:xfrm>
+      </p:grpSpPr>
+      <p:sp>
+        <p:nvSpPr>
+          <p:cNvPr id="2" name="Title 1"/>
+          <p:cNvSpPr>
+            <a:spLocks noGrp="1"/>
+          </p:cNvSpPr>
+          <p:nvPr>
+            <p:ph type="title"/>
+          </p:nvPr>
+        </p:nvSpPr>
+        <p:spPr/>
+        <p:txBody>
+          <a:bodyPr/>
+          <a:lstStyle/>
+          <a:p>
+            <a:pPr lvl="0" indent="0" marL="0">
+              <a:buNone/>
+            </a:pPr>
+            <a:r>
+              <a:rPr/>
+              <a:t>Baseline Results — Key Findings</a:t>
+            </a:r>
+          </a:p>
+        </p:txBody>
+      </p:sp>
+      <p:graphicFrame>
+        <p:nvGraphicFramePr>
+          <p:cNvPr id="6" name="Content Placeholder 5"/>
+          <p:cNvGraphicFramePr>
+            <a:graphicFrameLocks noGrp="1"/>
+          </p:cNvGraphicFramePr>
+          <p:nvPr>
+            <p:ph idx="1"/>
+          </p:nvPr>
+        </p:nvGraphicFramePr>
+        <p:xfrm>
+          <a:off x="457200" y="1193800"/>
+          <a:ext cx="8229600" cy="1574800"/>
+        </p:xfrm>
+        <a:graphic>
+          <a:graphicData uri="http://schemas.openxmlformats.org/drawingml/2006/table">
+            <a:tbl>
+              <a:tblPr firstRow="1" bandRow="1">
+                <a:tableStyleId>{5C22544A-7EE6-4342-B048-85BDC9FD1C3A}</a:tableStyleId>
+              </a:tblPr>
+              <a:tblGrid>
+                <a:gridCol w="2057400"/>
+                <a:gridCol w="2057400"/>
+                <a:gridCol w="2057400"/>
+                <a:gridCol w="2057400"/>
+              </a:tblGrid>
+              <a:tr h="0">
+                <a:tc>
+                  <a:txBody>
+                    <a:bodyPr/>
+                    <a:lstStyle/>
+                    <a:p>
+                      <a:pPr lvl="0" indent="0" marL="0">
+                        <a:buNone/>
+                      </a:pPr>
+                      <a:r>
+                        <a:rPr/>
+                        <a:t>Model</a:t>
+                      </a:r>
+                    </a:p>
+                  </a:txBody>
+                  <a:tcPr/>
+                </a:tc>
+                <a:tc>
+                  <a:txBody>
+                    <a:bodyPr/>
+                    <a:lstStyle/>
+                    <a:p>
+                      <a:pPr lvl="0" indent="0" marL="0">
+                        <a:buNone/>
+                      </a:pPr>
+                      <a:r>
+                        <a:rPr/>
+                        <a:t>Same-dataset Acc</a:t>
+                      </a:r>
+                    </a:p>
+                  </a:txBody>
+                  <a:tcPr/>
+                </a:tc>
+                <a:tc>
+                  <a:txBody>
+                    <a:bodyPr/>
+                    <a:lstStyle/>
+                    <a:p>
+                      <a:pPr lvl="0" indent="0" marL="0">
+                        <a:buNone/>
+                      </a:pPr>
+                      <a:r>
+                        <a:rPr/>
+                        <a:t>Cross-dataset Acc</a:t>
+                      </a:r>
+                    </a:p>
+                  </a:txBody>
+                  <a:tcPr/>
+                </a:tc>
+                <a:tc>
+                  <a:txBody>
+                    <a:bodyPr/>
+                    <a:lstStyle/>
+                    <a:p>
+                      <a:pPr lvl="0" indent="0" marL="0">
+                        <a:buNone/>
+                      </a:pPr>
+                      <a:r>
+                        <a:rPr/>
+                        <a:t>Cross-dataset Bal-Acc</a:t>
+                      </a:r>
+                    </a:p>
+                  </a:txBody>
+                  <a:tcPr/>
+                </a:tc>
+              </a:tr>
+              <a:tr h="0">
+                <a:tc>
+                  <a:txBody>
+                    <a:bodyPr/>
+                    <a:lstStyle/>
+                    <a:p>
+                      <a:pPr lvl="0" indent="0" marL="0">
+                        <a:buNone/>
+                      </a:pPr>
+                      <a:r>
+                        <a:rPr/>
+                        <a:t>Random Forest (</a:t>
+                      </a:r>
+                      <a:r>
+                        <a:rPr>
+                          <a:latin typeface="Courier"/>
+                        </a:rPr>
+                        <a:t>rf</a:t>
+                      </a:r>
+                      <a:r>
+                        <a:rPr/>
+                        <a:t>)</a:t>
+                      </a:r>
+                    </a:p>
+                  </a:txBody>
+                </a:tc>
+                <a:tc>
+                  <a:txBody>
+                    <a:bodyPr/>
+                    <a:lstStyle/>
+                    <a:p>
+                      <a:pPr lvl="0" indent="0" marL="0">
+                        <a:buNone/>
+                      </a:pPr>
+                      <a:r>
+                        <a:rPr b="1"/>
+                        <a:t>0.9666</a:t>
+                      </a:r>
+                    </a:p>
+                  </a:txBody>
+                </a:tc>
+                <a:tc>
+                  <a:txBody>
+                    <a:bodyPr/>
+                    <a:lstStyle/>
+                    <a:p>
+                      <a:pPr lvl="0" indent="0" marL="0">
+                        <a:buNone/>
+                      </a:pPr>
+                      <a:r>
+                        <a:rPr/>
+                        <a:t>0.3726</a:t>
+                      </a:r>
+                    </a:p>
+                  </a:txBody>
+                </a:tc>
+                <a:tc>
+                  <a:txBody>
+                    <a:bodyPr/>
+                    <a:lstStyle/>
+                    <a:p>
+                      <a:pPr lvl="0" indent="0" marL="0">
+                        <a:buNone/>
+                      </a:pPr>
+                      <a:r>
+                        <a:rPr/>
+                        <a:t>0.4650</a:t>
+                      </a:r>
+                    </a:p>
+                  </a:txBody>
+                </a:tc>
+              </a:tr>
+              <a:tr h="0">
+                <a:tc>
+                  <a:txBody>
+                    <a:bodyPr/>
+                    <a:lstStyle/>
+                    <a:p>
+                      <a:pPr lvl="0" indent="0" marL="0">
+                        <a:buNone/>
+                      </a:pPr>
+                      <a:r>
+                        <a:rPr/>
+                        <a:t>XGBoost (</a:t>
+                      </a:r>
+                      <a:r>
+                        <a:rPr>
+                          <a:latin typeface="Courier"/>
+                        </a:rPr>
+                        <a:t>xgb</a:t>
+                      </a:r>
+                      <a:r>
+                        <a:rPr/>
+                        <a:t>)</a:t>
+                      </a:r>
+                    </a:p>
+                  </a:txBody>
+                </a:tc>
+                <a:tc>
+                  <a:txBody>
+                    <a:bodyPr/>
+                    <a:lstStyle/>
+                    <a:p>
+                      <a:pPr lvl="0" indent="0" marL="0">
+                        <a:buNone/>
+                      </a:pPr>
+                      <a:r>
+                        <a:rPr/>
+                        <a:t>0.9622</a:t>
+                      </a:r>
+                    </a:p>
+                  </a:txBody>
+                </a:tc>
+                <a:tc>
+                  <a:txBody>
+                    <a:bodyPr/>
+                    <a:lstStyle/>
+                    <a:p>
+                      <a:pPr lvl="0" indent="0" marL="0">
+                        <a:buNone/>
+                      </a:pPr>
+                      <a:r>
+                        <a:rPr/>
+                        <a:t>0.4150</a:t>
+                      </a:r>
+                    </a:p>
+                  </a:txBody>
+                </a:tc>
+                <a:tc>
+                  <a:txBody>
+                    <a:bodyPr/>
+                    <a:lstStyle/>
+                    <a:p>
+                      <a:pPr lvl="0" indent="0" marL="0">
+                        <a:buNone/>
+                      </a:pPr>
+                      <a:r>
+                        <a:rPr/>
+                        <a:t>0.4760</a:t>
+                      </a:r>
+                    </a:p>
+                  </a:txBody>
+                </a:tc>
+              </a:tr>
+              <a:tr h="0">
+                <a:tc>
+                  <a:txBody>
+                    <a:bodyPr/>
+                    <a:lstStyle/>
+                    <a:p>
+                      <a:pPr lvl="0" indent="0" marL="0">
+                        <a:buNone/>
+                      </a:pPr>
+                      <a:r>
+                        <a:rPr/>
+                        <a:t>Hist. Grad. Boosting (</a:t>
+                      </a:r>
+                      <a:r>
+                        <a:rPr>
+                          <a:latin typeface="Courier"/>
+                        </a:rPr>
+                        <a:t>hgb</a:t>
+                      </a:r>
+                      <a:r>
+                        <a:rPr/>
+                        <a:t>)</a:t>
+                      </a:r>
+                    </a:p>
+                  </a:txBody>
+                </a:tc>
+                <a:tc>
+                  <a:txBody>
+                    <a:bodyPr/>
+                    <a:lstStyle/>
+                    <a:p>
+                      <a:pPr lvl="0" indent="0" marL="0">
+                        <a:buNone/>
+                      </a:pPr>
+                      <a:r>
+                        <a:rPr/>
+                        <a:t>0.9638</a:t>
+                      </a:r>
+                    </a:p>
+                  </a:txBody>
+                </a:tc>
+                <a:tc>
+                  <a:txBody>
+                    <a:bodyPr/>
+                    <a:lstStyle/>
+                    <a:p>
+                      <a:pPr lvl="0" indent="0" marL="0">
+                        <a:buNone/>
+                      </a:pPr>
+                      <a:r>
+                        <a:rPr b="1"/>
+                        <a:t>0.4179</a:t>
+                      </a:r>
+                    </a:p>
+                  </a:txBody>
+                </a:tc>
+                <a:tc>
+                  <a:txBody>
+                    <a:bodyPr/>
+                    <a:lstStyle/>
+                    <a:p>
+                      <a:pPr lvl="0" indent="0" marL="0">
+                        <a:buNone/>
+                      </a:pPr>
+                      <a:r>
+                        <a:rPr b="1"/>
+                        <a:t>0.4941</a:t>
+                      </a:r>
+                    </a:p>
+                  </a:txBody>
+                </a:tc>
+              </a:tr>
+              <a:tr h="0">
+                <a:tc>
+                  <a:txBody>
+                    <a:bodyPr/>
+                    <a:lstStyle/>
+                    <a:p>
+                      <a:pPr lvl="0" indent="0" marL="0">
+                        <a:buNone/>
+                      </a:pPr>
+                      <a:r>
+                        <a:rPr/>
+                        <a:t>Extra Trees (</a:t>
+                      </a:r>
+                      <a:r>
+                        <a:rPr>
+                          <a:latin typeface="Courier"/>
+                        </a:rPr>
+                        <a:t>et</a:t>
+                      </a:r>
+                      <a:r>
+                        <a:rPr/>
+                        <a:t>)</a:t>
+                      </a:r>
+                    </a:p>
+                  </a:txBody>
+                </a:tc>
+                <a:tc>
+                  <a:txBody>
+                    <a:bodyPr/>
+                    <a:lstStyle/>
+                    <a:p>
+                      <a:pPr lvl="0" indent="0" marL="0">
+                        <a:buNone/>
+                      </a:pPr>
+                      <a:r>
+                        <a:rPr/>
+                        <a:t>0.9602</a:t>
+                      </a:r>
+                    </a:p>
+                  </a:txBody>
+                </a:tc>
+                <a:tc>
+                  <a:txBody>
+                    <a:bodyPr/>
+                    <a:lstStyle/>
+                    <a:p>
+                      <a:pPr lvl="0" indent="0" marL="0">
+                        <a:buNone/>
+                      </a:pPr>
+                      <a:r>
+                        <a:rPr/>
+                        <a:t>0.4027</a:t>
+                      </a:r>
+                    </a:p>
+                  </a:txBody>
+                </a:tc>
+                <a:tc>
+                  <a:txBody>
+                    <a:bodyPr/>
+                    <a:lstStyle/>
+                    <a:p>
+                      <a:pPr lvl="0" indent="0" marL="0">
+                        <a:buNone/>
+                      </a:pPr>
+                      <a:r>
+                        <a:rPr/>
+                        <a:t>0.4672</a:t>
+                      </a:r>
+                    </a:p>
+                  </a:txBody>
+                </a:tc>
+              </a:tr>
+              <a:tr h="0">
+                <a:tc>
+                  <a:txBody>
+                    <a:bodyPr/>
+                    <a:lstStyle/>
+                    <a:p>
+                      <a:pPr lvl="0" indent="0" marL="0">
+                        <a:buNone/>
+                      </a:pPr>
+                      <a:r>
+                        <a:rPr/>
+                        <a:t>Soft-voting (</a:t>
+                      </a:r>
+                      <a:r>
+                        <a:rPr>
+                          <a:latin typeface="Courier"/>
+                        </a:rPr>
+                        <a:t>vote</a:t>
+                      </a:r>
+                      <a:r>
+                        <a:rPr/>
+                        <a:t>)</a:t>
+                      </a:r>
+                    </a:p>
+                  </a:txBody>
+                </a:tc>
+                <a:tc>
+                  <a:txBody>
+                    <a:bodyPr/>
+                    <a:lstStyle/>
+                    <a:p>
+                      <a:pPr lvl="0" indent="0" marL="0">
+                        <a:buNone/>
+                      </a:pPr>
+                      <a:r>
+                        <a:rPr/>
+                        <a:t>0.9656</a:t>
+                      </a:r>
+                    </a:p>
+                  </a:txBody>
+                </a:tc>
+                <a:tc>
+                  <a:txBody>
+                    <a:bodyPr/>
+                    <a:lstStyle/>
+                    <a:p>
+                      <a:pPr lvl="0" indent="0" marL="0">
+                        <a:buNone/>
+                      </a:pPr>
+                      <a:r>
+                        <a:rPr/>
+                        <a:t>0.3968</a:t>
+                      </a:r>
+                    </a:p>
+                  </a:txBody>
+                </a:tc>
+                <a:tc>
+                  <a:txBody>
+                    <a:bodyPr/>
+                    <a:lstStyle/>
+                    <a:p>
+                      <a:pPr lvl="0" indent="0" marL="0">
+                        <a:buNone/>
+                      </a:pPr>
+                      <a:r>
+                        <a:rPr/>
+                        <a:t>0.4624</a:t>
+                      </a:r>
+                    </a:p>
+                  </a:txBody>
+                </a:tc>
+              </a:tr>
+            </a:tbl>
+          </a:graphicData>
+        </a:graphic>
+      </p:graphicFrame>
+      <p:sp>
+        <p:nvSpPr>
+          <p:cNvPr id="3" name="Content Placeholder 2"/>
+          <p:cNvSpPr>
+            <a:spLocks noGrp="1"/>
+          </p:cNvSpPr>
+          <p:nvPr>
+            <p:ph idx="1"/>
+          </p:nvPr>
+        </p:nvSpPr>
+        <p:spPr>
+          <a:xfrm>
+            <a:off x="457200" y="2895600"/>
+            <a:ext cx="8229600" cy="1574800"/>
+          </a:xfrm>
+        </p:spPr>
+        <p:txBody>
+          <a:bodyPr/>
+          <a:lstStyle/>
+          <a:p>
+            <a:pPr lvl="0"/>
+            <a:r>
+              <a:rPr/>
+              <a:t>XGBoost CIC-IDS-2017 → UNSW-NB15 balanced accuracy = </a:t>
+            </a:r>
+            <a:r>
+              <a:rPr b="1"/>
+              <a:t>0.5000 (exactly random)</a:t>
+            </a:r>
+            <a:r>
+              <a:rPr/>
+              <a:t>.</a:t>
+            </a:r>
+          </a:p>
+          <a:p>
+            <a:pPr lvl="0"/>
+            <a:r>
+              <a:rPr b="1"/>
+              <a:t>Ensembling does NOT fix the gap</a:t>
+            </a:r>
+            <a:r>
+              <a:rPr/>
+              <a:t> → the problem is the features/distribution, not model capacity.</a:t>
+            </a:r>
+          </a:p>
+          <a:p>
+            <a:pPr lvl="0"/>
+            <a:r>
+              <a:rPr/>
+              <a:t>Independently matches the literature [1], [2]; motivates transfer-oriented optimisation.</a:t>
+            </a:r>
+          </a:p>
+        </p:txBody>
+      </p:sp>
+    </p:spTree>
+  </p:cSld>
+</p:sld>
+</file>
+
+<file path=ppt/slides/slide18.xml><?xml version="1.0" encoding="utf-8"?>
+<p:sld xmlns:a="http://schemas.openxmlformats.org/drawingml/2006/main" xmlns:r="http://schemas.openxmlformats.org/officeDocument/2006/relationships" xmlns:p="http://schemas.openxmlformats.org/presentationml/2006/main">
+  <p:cSld>
+    <p:spTree>
+      <p:nvGrpSpPr>
+        <p:cNvPr id="1" name=""/>
+        <p:cNvGrpSpPr/>
+        <p:nvPr/>
+      </p:nvGrpSpPr>
+      <p:grpSpPr>
+        <a:xfrm>
+          <a:off x="0" y="0"/>
+          <a:ext cx="0" cy="0"/>
+          <a:chOff x="0" y="0"/>
+          <a:chExt cx="0" cy="0"/>
+        </a:xfrm>
+      </p:grpSpPr>
+      <p:sp>
+        <p:nvSpPr>
+          <p:cNvPr id="2" name="Title 1"/>
+          <p:cNvSpPr>
+            <a:spLocks noGrp="1"/>
+          </p:cNvSpPr>
+          <p:nvPr>
+            <p:ph type="title"/>
+          </p:nvPr>
+        </p:nvSpPr>
+        <p:spPr/>
+        <p:txBody>
+          <a:bodyPr/>
+          <a:lstStyle/>
+          <a:p>
+            <a:pPr lvl="0" indent="0" marL="0">
+              <a:buNone/>
+            </a:pPr>
+            <a:r>
+              <a:rPr/>
+              <a:t>DA-MFS — Domain-Aligned Metaheuristic Feature Selection</a:t>
+            </a:r>
+          </a:p>
+        </p:txBody>
+      </p:sp>
+      <p:sp>
+        <p:nvSpPr>
+          <p:cNvPr id="3" name="Content Placeholder 2"/>
+          <p:cNvSpPr>
+            <a:spLocks noGrp="1"/>
+          </p:cNvSpPr>
+          <p:nvPr>
+            <p:ph idx="1"/>
+          </p:nvPr>
+        </p:nvSpPr>
+        <p:spPr>
+          <a:xfrm>
+            <a:off x="457200" y="1193800"/>
+            <a:ext cx="8229600" cy="1168400"/>
+          </a:xfrm>
+        </p:spPr>
+        <p:txBody>
+          <a:bodyPr/>
+          <a:lstStyle/>
+          <a:p>
+            <a:pPr lvl="0"/>
+            <a:r>
+              <a:rPr b="1"/>
+              <a:t>Why plain selection fails:</a:t>
+            </a:r>
+            <a:r>
+              <a:rPr/>
+              <a:t> the same feature has a </a:t>
+            </a:r>
+            <a:r>
+              <a:rPr i="1"/>
+              <a:t>different distribution</a:t>
+            </a:r>
+            <a:r>
+              <a:rPr/>
+              <a:t> in each dataset.</a:t>
+            </a:r>
+          </a:p>
+          <a:p>
+            <a:pPr lvl="0"/>
+            <a:r>
+              <a:rPr b="1"/>
+              <a:t>Stage 1 — Domain alignment:</a:t>
+            </a:r>
+            <a:r>
+              <a:rPr/>
+              <a:t> align each dataset’s feature marginals (per-dataset quantile transform → normal).</a:t>
+            </a:r>
+          </a:p>
+          <a:p>
+            <a:pPr lvl="0"/>
+            <a:r>
+              <a:rPr b="1"/>
+              <a:t>Stage 2 — Metaheuristic:</a:t>
+            </a:r>
+            <a:r>
+              <a:rPr/>
+              <a:t> GA / binary PSO search a feature subset with a </a:t>
+            </a:r>
+            <a:r>
+              <a:rPr b="1"/>
+              <a:t>cross-dataset fitness</a:t>
+            </a:r>
+            <a:r>
+              <a:rPr/>
+              <a:t> (mean balanced-accuracy + macro-F1 over 6 pairs).</a:t>
+            </a:r>
+          </a:p>
+          <a:p>
+            <a:pPr lvl="0"/>
+            <a:r>
+              <a:rPr b="1"/>
+              <a:t>Novelty:</a:t>
+            </a:r>
+            <a:r>
+              <a:rPr/>
+              <a:t> no prior work couples domain alignment with metaheuristic feature selection for NIDS.</a:t>
+            </a:r>
+          </a:p>
+        </p:txBody>
+      </p:sp>
+      <p:graphicFrame>
+        <p:nvGraphicFramePr>
+          <p:cNvPr id="6" name="Content Placeholder 5"/>
+          <p:cNvGraphicFramePr>
+            <a:graphicFrameLocks noGrp="1"/>
+          </p:cNvGraphicFramePr>
+          <p:nvPr>
+            <p:ph idx="1"/>
+          </p:nvPr>
+        </p:nvGraphicFramePr>
+        <p:xfrm>
+          <a:off x="457200" y="2489200"/>
+          <a:ext cx="8229600" cy="685800"/>
+        </p:xfrm>
+        <a:graphic>
+          <a:graphicData uri="http://schemas.openxmlformats.org/drawingml/2006/table">
+            <a:tbl>
+              <a:tblPr firstRow="1" bandRow="1">
+                <a:tableStyleId>{5C22544A-7EE6-4342-B048-85BDC9FD1C3A}</a:tableStyleId>
+              </a:tblPr>
+              <a:tblGrid>
+                <a:gridCol w="2057400"/>
+                <a:gridCol w="2057400"/>
+                <a:gridCol w="2057400"/>
+                <a:gridCol w="2057400"/>
+              </a:tblGrid>
+              <a:tr h="0">
+                <a:tc>
+                  <a:txBody>
+                    <a:bodyPr/>
+                    <a:lstStyle/>
+                    <a:p>
+                      <a:pPr lvl="0" indent="0" marL="0">
+                        <a:buNone/>
+                      </a:pPr>
+                      <a:r>
+                        <a:rPr/>
+                        <a:t>Cross-dataset metric</a:t>
+                      </a:r>
+                    </a:p>
+                  </a:txBody>
+                  <a:tcPr/>
+                </a:tc>
+                <a:tc>
+                  <a:txBody>
+                    <a:bodyPr/>
+                    <a:lstStyle/>
+                    <a:p>
+                      <a:pPr lvl="0" indent="0" marL="0">
+                        <a:buNone/>
+                      </a:pPr>
+                      <a:r>
+                        <a:rPr/>
+                        <a:t>Raw baseline</a:t>
+                      </a:r>
+                    </a:p>
+                  </a:txBody>
+                  <a:tcPr/>
+                </a:tc>
+                <a:tc>
+                  <a:txBody>
+                    <a:bodyPr/>
+                    <a:lstStyle/>
+                    <a:p>
+                      <a:pPr lvl="0" indent="0" marL="0">
+                        <a:buNone/>
+                      </a:pPr>
+                      <a:r>
+                        <a:rPr b="1"/>
+                        <a:t>DA-MFS</a:t>
+                      </a:r>
+                    </a:p>
+                  </a:txBody>
+                  <a:tcPr/>
+                </a:tc>
+                <a:tc>
+                  <a:txBody>
+                    <a:bodyPr/>
+                    <a:lstStyle/>
+                    <a:p>
+                      <a:pPr lvl="0" indent="0" marL="0">
+                        <a:buNone/>
+                      </a:pPr>
+                      <a:r>
+                        <a:rPr/>
+                        <a:t>Change</a:t>
+                      </a:r>
+                    </a:p>
+                  </a:txBody>
+                  <a:tcPr/>
+                </a:tc>
+              </a:tr>
+              <a:tr h="0">
+                <a:tc>
+                  <a:txBody>
+                    <a:bodyPr/>
+                    <a:lstStyle/>
+                    <a:p>
+                      <a:pPr lvl="0" indent="0" marL="0">
+                        <a:buNone/>
+                      </a:pPr>
+                      <a:r>
+                        <a:rPr/>
+                        <a:t>Accuracy</a:t>
+                      </a:r>
+                    </a:p>
+                  </a:txBody>
+                </a:tc>
+                <a:tc>
+                  <a:txBody>
+                    <a:bodyPr/>
+                    <a:lstStyle/>
+                    <a:p>
+                      <a:pPr lvl="0" indent="0" marL="0">
+                        <a:buNone/>
+                      </a:pPr>
+                      <a:r>
+                        <a:rPr/>
+                        <a:t>0.373</a:t>
+                      </a:r>
+                    </a:p>
+                  </a:txBody>
+                </a:tc>
+                <a:tc>
+                  <a:txBody>
+                    <a:bodyPr/>
+                    <a:lstStyle/>
+                    <a:p>
+                      <a:pPr lvl="0" indent="0" marL="0">
+                        <a:buNone/>
+                      </a:pPr>
+                      <a:r>
+                        <a:rPr b="1"/>
+                        <a:t>0.508</a:t>
+                      </a:r>
+                    </a:p>
+                  </a:txBody>
+                </a:tc>
+                <a:tc>
+                  <a:txBody>
+                    <a:bodyPr/>
+                    <a:lstStyle/>
+                    <a:p>
+                      <a:pPr lvl="0" indent="0" marL="0">
+                        <a:buNone/>
+                      </a:pPr>
+                      <a:r>
+                        <a:rPr b="1"/>
+                        <a:t>+0.136</a:t>
+                      </a:r>
+                    </a:p>
+                  </a:txBody>
+                </a:tc>
+              </a:tr>
+              <a:tr h="0">
+                <a:tc>
+                  <a:txBody>
+                    <a:bodyPr/>
+                    <a:lstStyle/>
+                    <a:p>
+                      <a:pPr lvl="0" indent="0" marL="0">
+                        <a:buNone/>
+                      </a:pPr>
+                      <a:r>
+                        <a:rPr/>
+                        <a:t>Balanced accuracy</a:t>
+                      </a:r>
+                    </a:p>
+                  </a:txBody>
+                </a:tc>
+                <a:tc>
+                  <a:txBody>
+                    <a:bodyPr/>
+                    <a:lstStyle/>
+                    <a:p>
+                      <a:pPr lvl="0" indent="0" marL="0">
+                        <a:buNone/>
+                      </a:pPr>
+                      <a:r>
+                        <a:rPr/>
+                        <a:t>0.465</a:t>
+                      </a:r>
+                    </a:p>
+                  </a:txBody>
+                </a:tc>
+                <a:tc>
+                  <a:txBody>
+                    <a:bodyPr/>
+                    <a:lstStyle/>
+                    <a:p>
+                      <a:pPr lvl="0" indent="0" marL="0">
+                        <a:buNone/>
+                      </a:pPr>
+                      <a:r>
+                        <a:rPr b="1"/>
+                        <a:t>0.569</a:t>
+                      </a:r>
+                    </a:p>
+                  </a:txBody>
+                </a:tc>
+                <a:tc>
+                  <a:txBody>
+                    <a:bodyPr/>
+                    <a:lstStyle/>
+                    <a:p>
+                      <a:pPr lvl="0" indent="0" marL="0">
+                        <a:buNone/>
+                      </a:pPr>
+                      <a:r>
+                        <a:rPr b="1"/>
+                        <a:t>+0.104</a:t>
+                      </a:r>
+                    </a:p>
+                  </a:txBody>
+                </a:tc>
+              </a:tr>
+              <a:tr h="0">
+                <a:tc>
+                  <a:txBody>
+                    <a:bodyPr/>
+                    <a:lstStyle/>
+                    <a:p>
+                      <a:pPr lvl="0" indent="0" marL="0">
+                        <a:buNone/>
+                      </a:pPr>
+                      <a:r>
+                        <a:rPr/>
+                        <a:t>Macro-F1</a:t>
+                      </a:r>
+                    </a:p>
+                  </a:txBody>
+                </a:tc>
+                <a:tc>
+                  <a:txBody>
+                    <a:bodyPr/>
+                    <a:lstStyle/>
+                    <a:p>
+                      <a:pPr lvl="0" indent="0" marL="0">
+                        <a:buNone/>
+                      </a:pPr>
+                      <a:r>
+                        <a:rPr/>
+                        <a:t>0.308</a:t>
+                      </a:r>
+                    </a:p>
+                  </a:txBody>
+                </a:tc>
+                <a:tc>
+                  <a:txBody>
+                    <a:bodyPr/>
+                    <a:lstStyle/>
+                    <a:p>
+                      <a:pPr lvl="0" indent="0" marL="0">
+                        <a:buNone/>
+                      </a:pPr>
+                      <a:r>
+                        <a:rPr b="1"/>
+                        <a:t>0.460</a:t>
+                      </a:r>
+                    </a:p>
+                  </a:txBody>
+                </a:tc>
+                <a:tc>
+                  <a:txBody>
+                    <a:bodyPr/>
+                    <a:lstStyle/>
+                    <a:p>
+                      <a:pPr lvl="0" indent="0" marL="0">
+                        <a:buNone/>
+                      </a:pPr>
+                      <a:r>
+                        <a:rPr b="1"/>
+                        <a:t>+0.153</a:t>
+                      </a:r>
+                    </a:p>
+                  </a:txBody>
+                </a:tc>
+              </a:tr>
+              <a:tr h="0">
+                <a:tc>
+                  <a:txBody>
+                    <a:bodyPr/>
+                    <a:lstStyle/>
+                    <a:p>
+                      <a:pPr lvl="0" indent="0" marL="0">
+                        <a:buNone/>
+                      </a:pPr>
+                      <a:r>
+                        <a:rPr/>
+                        <a:t>Attack recall</a:t>
+                      </a:r>
+                    </a:p>
+                  </a:txBody>
+                </a:tc>
+                <a:tc>
+                  <a:txBody>
+                    <a:bodyPr/>
+                    <a:lstStyle/>
+                    <a:p>
+                      <a:pPr lvl="0" indent="0" marL="0">
+                        <a:buNone/>
+                      </a:pPr>
+                      <a:r>
+                        <a:rPr/>
+                        <a:t>0.479</a:t>
+                      </a:r>
+                    </a:p>
+                  </a:txBody>
+                </a:tc>
+                <a:tc>
+                  <a:txBody>
+                    <a:bodyPr/>
+                    <a:lstStyle/>
+                    <a:p>
+                      <a:pPr lvl="0" indent="0" marL="0">
+                        <a:buNone/>
+                      </a:pPr>
+                      <a:r>
+                        <a:rPr b="1"/>
+                        <a:t>0.607</a:t>
+                      </a:r>
+                    </a:p>
+                  </a:txBody>
+                </a:tc>
+                <a:tc>
+                  <a:txBody>
+                    <a:bodyPr/>
+                    <a:lstStyle/>
+                    <a:p>
+                      <a:pPr lvl="0" indent="0" marL="0">
+                        <a:buNone/>
+                      </a:pPr>
+                      <a:r>
+                        <a:rPr b="1"/>
+                        <a:t>+0.128</a:t>
+                      </a:r>
+                    </a:p>
+                  </a:txBody>
+                </a:tc>
+              </a:tr>
+            </a:tbl>
+          </a:graphicData>
+        </a:graphic>
+      </p:graphicFrame>
+      <p:sp>
+        <p:nvSpPr>
+          <p:cNvPr id="3" name="Content Placeholder 2"/>
+          <p:cNvSpPr>
+            <a:spLocks noGrp="1"/>
+          </p:cNvSpPr>
+          <p:nvPr>
+            <p:ph idx="1"/>
+          </p:nvPr>
+        </p:nvSpPr>
+        <p:spPr>
+          <a:xfrm>
+            <a:off x="457200" y="3949700"/>
+            <a:ext cx="8229600" cy="520700"/>
+          </a:xfrm>
+        </p:spPr>
+        <p:txBody>
+          <a:bodyPr/>
+          <a:lstStyle/>
+          <a:p>
+            <a:pPr lvl="0"/>
+            <a:r>
+              <a:rPr/>
+              <a:t>Compact </a:t>
+            </a:r>
+            <a:r>
+              <a:rPr b="1"/>
+              <a:t>4-feature</a:t>
+            </a:r>
+            <a:r>
+              <a:rPr/>
+              <a:t> subset; </a:t>
+            </a:r>
+            <a:r>
+              <a:rPr b="1"/>
+              <a:t>+13.6 pp accuracy and +12.8 pp recall</a:t>
+            </a:r>
+            <a:r>
+              <a:rPr/>
+              <a:t> — a clear, defensible gain.</a:t>
+            </a:r>
+          </a:p>
+          <a:p>
+            <a:pPr lvl="0"/>
+            <a:r>
+              <a:rPr/>
+              <a:t>Next: GA vs PSO vs DE, NSGA-II multi-objective, divergence-aware fitness, standard FS baselines.</a:t>
+            </a:r>
+          </a:p>
+        </p:txBody>
+      </p:sp>
+    </p:spTree>
+  </p:cSld>
+</p:sld>
+</file>
+
+<file path=ppt/slides/slide19.xml><?xml version="1.0" encoding="utf-8"?>
 <p:sld xmlns:a="http://schemas.openxmlformats.org/drawingml/2006/main" xmlns:r="http://schemas.openxmlformats.org/officeDocument/2006/relationships" xmlns:p="http://schemas.openxmlformats.org/presentationml/2006/main">
   <p:cSld>
     <p:spTree>
@@ -5826,396 +6916,6 @@
 </p:sld>
 </file>
 
-<file path=ppt/slides/slide18.xml><?xml version="1.0" encoding="utf-8"?>
-<p:sld xmlns:a="http://schemas.openxmlformats.org/drawingml/2006/main" xmlns:r="http://schemas.openxmlformats.org/officeDocument/2006/relationships" xmlns:p="http://schemas.openxmlformats.org/presentationml/2006/main">
-  <p:cSld>
-    <p:spTree>
-      <p:nvGrpSpPr>
-        <p:cNvPr id="1" name=""/>
-        <p:cNvGrpSpPr/>
-        <p:nvPr/>
-      </p:nvGrpSpPr>
-      <p:grpSpPr>
-        <a:xfrm>
-          <a:off x="0" y="0"/>
-          <a:ext cx="0" cy="0"/>
-          <a:chOff x="0" y="0"/>
-          <a:chExt cx="0" cy="0"/>
-        </a:xfrm>
-      </p:grpSpPr>
-      <p:sp>
-        <p:nvSpPr>
-          <p:cNvPr id="2" name="Title 1"/>
-          <p:cNvSpPr>
-            <a:spLocks noGrp="1"/>
-          </p:cNvSpPr>
-          <p:nvPr>
-            <p:ph type="title"/>
-          </p:nvPr>
-        </p:nvSpPr>
-        <p:spPr/>
-        <p:txBody>
-          <a:bodyPr/>
-          <a:lstStyle/>
-          <a:p>
-            <a:pPr lvl="0" indent="0" marL="0">
-              <a:buNone/>
-            </a:pPr>
-            <a:r>
-              <a:rPr/>
-              <a:t>Conclusion &amp; Future Work</a:t>
-            </a:r>
-          </a:p>
-        </p:txBody>
-      </p:sp>
-      <p:sp>
-        <p:nvSpPr>
-          <p:cNvPr id="3" name="Content Placeholder 2"/>
-          <p:cNvSpPr>
-            <a:spLocks noGrp="1"/>
-          </p:cNvSpPr>
-          <p:nvPr>
-            <p:ph idx="1"/>
-          </p:nvPr>
-        </p:nvSpPr>
-        <p:spPr/>
-        <p:txBody>
-          <a:bodyPr/>
-          <a:lstStyle/>
-          <a:p>
-            <a:pPr lvl="0" indent="0" marL="0">
-              <a:buNone/>
-            </a:pPr>
-            <a:r>
-              <a:rPr b="1"/>
-              <a:t>Conclusion</a:t>
-            </a:r>
-          </a:p>
-          <a:p>
-            <a:pPr lvl="0"/>
-            <a:r>
-              <a:rPr/>
-              <a:t>Three structurally different benchmarks analysed; </a:t>
-            </a:r>
-            <a:r>
-              <a:rPr b="1"/>
-              <a:t>feature-schema mismatch</a:t>
-            </a:r>
-            <a:r>
-              <a:rPr/>
-              <a:t> is the root cause of cross-dataset failure.</a:t>
-            </a:r>
-          </a:p>
-          <a:p>
-            <a:pPr lvl="0"/>
-            <a:r>
-              <a:rPr/>
-              <a:t>Literature review (15 core papers) confirms a clear gap: no transfer-optimised metaheuristic feature selection for NIDS.</a:t>
-            </a:r>
-          </a:p>
-          <a:p>
-            <a:pPr lvl="0"/>
-            <a:r>
-              <a:rPr/>
-              <a:t>Objectives and a seven-phase methodology defined; codebase and tooling set up.</a:t>
-            </a:r>
-          </a:p>
-          <a:p>
-            <a:pPr lvl="0" indent="0" marL="0">
-              <a:buNone/>
-            </a:pPr>
-            <a:r>
-              <a:rPr b="1"/>
-              <a:t>Future work</a:t>
-            </a:r>
-          </a:p>
-          <a:p>
-            <a:pPr lvl="0" indent="-342900" marL="342900">
-              <a:buAutoNum type="arabicPeriod"/>
-            </a:pPr>
-            <a:r>
-              <a:rPr/>
-              <a:t>Cleaning &amp; feature harmonisation.</a:t>
-            </a:r>
-          </a:p>
-          <a:p>
-            <a:pPr lvl="0" indent="-342900" marL="342900">
-              <a:buAutoNum type="arabicPeriod"/>
-            </a:pPr>
-            <a:r>
-              <a:rPr/>
-              <a:t>Cross-dataset baseline benchmark (3×3 matrix).</a:t>
-            </a:r>
-          </a:p>
-          <a:p>
-            <a:pPr lvl="0" indent="-342900" marL="342900">
-              <a:buAutoNum type="arabicPeriod"/>
-            </a:pPr>
-            <a:r>
-              <a:rPr/>
-              <a:t>GA / PSO / DE transfer-oriented feature selection.</a:t>
-            </a:r>
-          </a:p>
-          <a:p>
-            <a:pPr lvl="0" indent="-342900" marL="342900">
-              <a:buAutoNum type="arabicPeriod"/>
-            </a:pPr>
-            <a:r>
-              <a:rPr/>
-              <a:t>Comparison vs. standard feature-selection baselines.</a:t>
-            </a:r>
-          </a:p>
-          <a:p>
-            <a:pPr lvl="0" indent="-342900" marL="342900">
-              <a:buAutoNum type="arabicPeriod"/>
-            </a:pPr>
-            <a:r>
-              <a:rPr/>
-              <a:t>Analysis of transferable features/attacks + ablations.</a:t>
-            </a:r>
-          </a:p>
-          <a:p>
-            <a:pPr lvl="0" indent="-342900" marL="342900">
-              <a:buAutoNum type="arabicPeriod"/>
-            </a:pPr>
-            <a:r>
-              <a:rPr/>
-              <a:t>Practical guidelines and final report.</a:t>
-            </a:r>
-          </a:p>
-        </p:txBody>
-      </p:sp>
-    </p:spTree>
-  </p:cSld>
-</p:sld>
-</file>
-
-<file path=ppt/slides/slide19.xml><?xml version="1.0" encoding="utf-8"?>
-<p:sld xmlns:a="http://schemas.openxmlformats.org/drawingml/2006/main" xmlns:r="http://schemas.openxmlformats.org/officeDocument/2006/relationships" xmlns:p="http://schemas.openxmlformats.org/presentationml/2006/main">
-  <p:cSld>
-    <p:spTree>
-      <p:nvGrpSpPr>
-        <p:cNvPr id="1" name=""/>
-        <p:cNvGrpSpPr/>
-        <p:nvPr/>
-      </p:nvGrpSpPr>
-      <p:grpSpPr>
-        <a:xfrm>
-          <a:off x="0" y="0"/>
-          <a:ext cx="0" cy="0"/>
-          <a:chOff x="0" y="0"/>
-          <a:chExt cx="0" cy="0"/>
-        </a:xfrm>
-      </p:grpSpPr>
-      <p:sp>
-        <p:nvSpPr>
-          <p:cNvPr id="2" name="Title 1"/>
-          <p:cNvSpPr>
-            <a:spLocks noGrp="1"/>
-          </p:cNvSpPr>
-          <p:nvPr>
-            <p:ph type="title"/>
-          </p:nvPr>
-        </p:nvSpPr>
-        <p:spPr/>
-        <p:txBody>
-          <a:bodyPr/>
-          <a:lstStyle/>
-          <a:p>
-            <a:pPr lvl="0" indent="0" marL="0">
-              <a:buNone/>
-            </a:pPr>
-            <a:r>
-              <a:rPr/>
-              <a:t>References</a:t>
-            </a:r>
-          </a:p>
-        </p:txBody>
-      </p:sp>
-      <p:sp>
-        <p:nvSpPr>
-          <p:cNvPr id="3" name="Content Placeholder 2"/>
-          <p:cNvSpPr>
-            <a:spLocks noGrp="1"/>
-          </p:cNvSpPr>
-          <p:nvPr>
-            <p:ph idx="1"/>
-          </p:nvPr>
-        </p:nvSpPr>
-        <p:spPr/>
-        <p:txBody>
-          <a:bodyPr/>
-          <a:lstStyle/>
-          <a:p>
-            <a:pPr lvl="0" indent="0" marL="0">
-              <a:buNone/>
-            </a:pPr>
-            <a:r>
-              <a:rPr/>
-              <a:t>[1] Cantone, Marrocco, Bria, “On the cross-dataset generalization of machine learning for network intrusion detection,” </a:t>
-            </a:r>
-            <a:r>
-              <a:rPr i="1"/>
-              <a:t>IEEE Access</a:t>
-            </a:r>
-            <a:r>
-              <a:rPr/>
-              <a:t>, 2024.</a:t>
-            </a:r>
-          </a:p>
-          <a:p>
-            <a:pPr lvl="0" indent="0" marL="0">
-              <a:buNone/>
-            </a:pPr>
-            <a:r>
-              <a:rPr/>
-              <a:t>[2] Hossain et al., “Assessing generalisation capability of machine learning models for intrusion detection,” arXiv:2605.04407, 2026.</a:t>
-            </a:r>
-          </a:p>
-          <a:p>
-            <a:pPr lvl="0" indent="0" marL="0">
-              <a:buNone/>
-            </a:pPr>
-            <a:r>
-              <a:rPr/>
-              <a:t>[3] Hakim, Uddin, Anis, “Cross-domain generalization failure in lightweight intrusion detection models for IIoT networks,” arXiv:2607.00553, 2026.</a:t>
-            </a:r>
-          </a:p>
-          <a:p>
-            <a:pPr lvl="0" indent="0" marL="0">
-              <a:buNone/>
-            </a:pPr>
-            <a:r>
-              <a:rPr/>
-              <a:t>[4] Butt, Hotho, Schlör, “Evaluating tabular representation learning for network intrusion detection,” </a:t>
-            </a:r>
-            <a:r>
-              <a:rPr i="1"/>
-              <a:t>IEEE CSR</a:t>
-            </a:r>
-            <a:r>
-              <a:rPr/>
-              <a:t>, 2026.</a:t>
-            </a:r>
-          </a:p>
-          <a:p>
-            <a:pPr lvl="0" indent="0" marL="0">
-              <a:buNone/>
-            </a:pPr>
-            <a:r>
-              <a:rPr/>
-              <a:t>[5] Sharafaldin, Lashkari, Ghorbani, “Toward generating a new intrusion detection dataset…” (CIC-IDS-2017), </a:t>
-            </a:r>
-            <a:r>
-              <a:rPr i="1"/>
-              <a:t>ICISSP</a:t>
-            </a:r>
-            <a:r>
-              <a:rPr/>
-              <a:t>, 2018.</a:t>
-            </a:r>
-          </a:p>
-          <a:p>
-            <a:pPr lvl="0" indent="0" marL="0">
-              <a:buNone/>
-            </a:pPr>
-            <a:r>
-              <a:rPr/>
-              <a:t>[6] Moustafa, Slay, “UNSW-NB15: a comprehensive data set…”, </a:t>
-            </a:r>
-            <a:r>
-              <a:rPr i="1"/>
-              <a:t>MilCIS</a:t>
-            </a:r>
-            <a:r>
-              <a:rPr/>
-              <a:t>, 2015.</a:t>
-            </a:r>
-          </a:p>
-          <a:p>
-            <a:pPr lvl="0" indent="0" marL="0">
-              <a:buNone/>
-            </a:pPr>
-            <a:r>
-              <a:rPr/>
-              <a:t>[7] Moustafa, “Network TON_IoT datasets,” </a:t>
-            </a:r>
-            <a:r>
-              <a:rPr i="1"/>
-              <a:t>Sustainable Cities and Society</a:t>
-            </a:r>
-            <a:r>
-              <a:rPr/>
-              <a:t>, 2021.</a:t>
-            </a:r>
-          </a:p>
-          <a:p>
-            <a:pPr lvl="0" indent="0" marL="0">
-              <a:buNone/>
-            </a:pPr>
-            <a:r>
-              <a:rPr/>
-              <a:t>[8]–[12] Fatima &amp; Ali (2022); Suman et al. (2019); Li (2026); Mojtahedi et al. (2022); Yang et al. (2026).</a:t>
-            </a:r>
-          </a:p>
-          <a:p>
-            <a:pPr lvl="0" indent="0" marL="0">
-              <a:buNone/>
-            </a:pPr>
-            <a:r>
-              <a:rPr/>
-              <a:t>[13] Layeghy, Baktashmotlagh, Portmann, “DI-NIDS,” </a:t>
-            </a:r>
-            <a:r>
-              <a:rPr i="1"/>
-              <a:t>Knowledge-Based Systems</a:t>
-            </a:r>
-            <a:r>
-              <a:rPr/>
-              <a:t>, 2023.</a:t>
-            </a:r>
-          </a:p>
-          <a:p>
-            <a:pPr lvl="0" indent="0" marL="0">
-              <a:buNone/>
-            </a:pPr>
-            <a:r>
-              <a:rPr/>
-              <a:t>[14] Ring et al., “A survey of network-based intrusion detection data sets,” </a:t>
-            </a:r>
-            <a:r>
-              <a:rPr i="1"/>
-              <a:t>Computers &amp; Security</a:t>
-            </a:r>
-            <a:r>
-              <a:rPr/>
-              <a:t>, 2019.</a:t>
-            </a:r>
-          </a:p>
-          <a:p>
-            <a:pPr lvl="0" indent="0" marL="0">
-              <a:buNone/>
-            </a:pPr>
-            <a:r>
-              <a:rPr/>
-              <a:t>[15] Vitorino et al., “An adversarial robustness benchmark for enterprise NIDS,” </a:t>
-            </a:r>
-            <a:r>
-              <a:rPr i="1"/>
-              <a:t>FPS</a:t>
-            </a:r>
-            <a:r>
-              <a:rPr/>
-              <a:t>, 2023.</a:t>
-            </a:r>
-          </a:p>
-        </p:txBody>
-      </p:sp>
-    </p:spTree>
-  </p:cSld>
-</p:sld>
-</file>
-
 <file path=ppt/slides/slide2.xml><?xml version="1.0" encoding="utf-8"?>
 <p:sld xmlns:a="http://schemas.openxmlformats.org/drawingml/2006/main" xmlns:r="http://schemas.openxmlformats.org/officeDocument/2006/relationships" xmlns:p="http://schemas.openxmlformats.org/presentationml/2006/main">
   <p:cSld>
@@ -6386,7 +7086,16 @@
             </a:pPr>
             <a:r>
               <a:rPr/>
-              <a:t>Results &amp; Discussion</a:t>
+              <a:t>Baseline Cross-Dataset Results</a:t>
+            </a:r>
+          </a:p>
+          <a:p>
+            <a:pPr lvl="0" indent="-342900" marL="342900">
+              <a:buAutoNum type="arabicPeriod"/>
+            </a:pPr>
+            <a:r>
+              <a:rPr/>
+              <a:t>DA-MFS (Optimisation Result)</a:t>
             </a:r>
           </a:p>
           <a:p>
@@ -6460,7 +7169,7 @@
             </a:pPr>
             <a:r>
               <a:rPr/>
-              <a:t>Thank You</a:t>
+              <a:t>Conclusion &amp; Future Work</a:t>
             </a:r>
           </a:p>
         </p:txBody>
@@ -6485,7 +7194,67 @@
             </a:pPr>
             <a:r>
               <a:rPr b="1"/>
-              <a:t>Questions?</a:t>
+              <a:t>Conclusion</a:t>
+            </a:r>
+          </a:p>
+          <a:p>
+            <a:pPr lvl="0"/>
+            <a:r>
+              <a:rPr/>
+              <a:t>Three structurally different benchmarks analysed; </a:t>
+            </a:r>
+            <a:r>
+              <a:rPr b="1"/>
+              <a:t>feature-schema mismatch</a:t>
+            </a:r>
+            <a:r>
+              <a:rPr/>
+              <a:t> is the root cause of cross-dataset failure.</a:t>
+            </a:r>
+          </a:p>
+          <a:p>
+            <a:pPr lvl="0"/>
+            <a:r>
+              <a:rPr/>
+              <a:t>Literature review (15 core papers) confirms a clear gap: no transfer-optimised metaheuristic feature selection for NIDS.</a:t>
+            </a:r>
+          </a:p>
+          <a:p>
+            <a:pPr lvl="0"/>
+            <a:r>
+              <a:rPr b="1"/>
+              <a:t>Baseline quantified the gap:</a:t>
+            </a:r>
+            <a:r>
+              <a:rPr/>
+              <a:t> 0.96–0.97 same-dataset vs 0.37–0.42 cross-dataset (balanced accuracy ≈ random chance).</a:t>
+            </a:r>
+          </a:p>
+          <a:p>
+            <a:pPr lvl="0"/>
+            <a:r>
+              <a:rPr b="1"/>
+              <a:t>DA-MFS optimisation works:</a:t>
+            </a:r>
+            <a:r>
+              <a:rPr/>
+              <a:t> domain alignment + evolutionary feature selection lifts cross-dataset accuracy </a:t>
+            </a:r>
+            <a:r>
+              <a:rPr b="1"/>
+              <a:t>0.373 → 0.508</a:t>
+            </a:r>
+            <a:r>
+              <a:rPr/>
+              <a:t> and recall </a:t>
+            </a:r>
+            <a:r>
+              <a:rPr b="1"/>
+              <a:t>0.479 → 0.607</a:t>
+            </a:r>
+            <a:r>
+              <a:rPr/>
+              <a:t>.</a:t>
             </a:r>
           </a:p>
           <a:p>
@@ -6493,26 +7262,270 @@
               <a:buNone/>
             </a:pPr>
             <a:r>
-              <a:rPr/>
-              <a:t>Evaluating and Improving Cross-Dataset Generalization of ML-Based Intrusion Detection Systems</a:t>
-            </a:r>
-          </a:p>
+              <a:rPr b="1"/>
+              <a:t>Future work</a:t>
+            </a:r>
+          </a:p>
+          <a:p>
+            <a:pPr lvl="0" indent="-342900" marL="342900">
+              <a:buAutoNum type="arabicPeriod"/>
+            </a:pPr>
+            <a:r>
+              <a:rPr/>
+              <a:t>Extend DA-MFS (GA / PSO / DE / NSGA-II, divergence-aware fitness).</a:t>
+            </a:r>
+          </a:p>
+          <a:p>
+            <a:pPr lvl="0" indent="-342900" marL="342900">
+              <a:buAutoNum type="arabicPeriod"/>
+            </a:pPr>
+            <a:r>
+              <a:rPr/>
+              <a:t>Comparison vs. standard feature-selection baselines.</a:t>
+            </a:r>
+          </a:p>
+          <a:p>
+            <a:pPr lvl="0" indent="-342900" marL="342900">
+              <a:buAutoNum type="arabicPeriod"/>
+            </a:pPr>
+            <a:r>
+              <a:rPr/>
+              <a:t>Analysis of transferable features/attacks + ablations.</a:t>
+            </a:r>
+          </a:p>
+          <a:p>
+            <a:pPr lvl="0" indent="-342900" marL="342900">
+              <a:buAutoNum type="arabicPeriod"/>
+            </a:pPr>
+            <a:r>
+              <a:rPr/>
+              <a:t>Practical guidelines and final report.</a:t>
+            </a:r>
+          </a:p>
+        </p:txBody>
+      </p:sp>
+    </p:spTree>
+  </p:cSld>
+</p:sld>
+</file>
+
+<file path=ppt/slides/slide21.xml><?xml version="1.0" encoding="utf-8"?>
+<p:sld xmlns:a="http://schemas.openxmlformats.org/drawingml/2006/main" xmlns:r="http://schemas.openxmlformats.org/officeDocument/2006/relationships" xmlns:p="http://schemas.openxmlformats.org/presentationml/2006/main">
+  <p:cSld>
+    <p:spTree>
+      <p:nvGrpSpPr>
+        <p:cNvPr id="1" name=""/>
+        <p:cNvGrpSpPr/>
+        <p:nvPr/>
+      </p:nvGrpSpPr>
+      <p:grpSpPr>
+        <a:xfrm>
+          <a:off x="0" y="0"/>
+          <a:ext cx="0" cy="0"/>
+          <a:chOff x="0" y="0"/>
+          <a:chExt cx="0" cy="0"/>
+        </a:xfrm>
+      </p:grpSpPr>
+      <p:sp>
+        <p:nvSpPr>
+          <p:cNvPr id="2" name="Title 1"/>
+          <p:cNvSpPr>
+            <a:spLocks noGrp="1"/>
+          </p:cNvSpPr>
+          <p:nvPr>
+            <p:ph type="title"/>
+          </p:nvPr>
+        </p:nvSpPr>
+        <p:spPr/>
+        <p:txBody>
+          <a:bodyPr/>
+          <a:lstStyle/>
           <a:p>
             <a:pPr lvl="0" indent="0" marL="0">
               <a:buNone/>
             </a:pPr>
             <a:r>
               <a:rPr/>
-              <a:t>Shivam Chauhan · Deepesh · Shantanu Agarwal</a:t>
-            </a:r>
-          </a:p>
+              <a:t>References</a:t>
+            </a:r>
+          </a:p>
+        </p:txBody>
+      </p:sp>
+      <p:sp>
+        <p:nvSpPr>
+          <p:cNvPr id="3" name="Content Placeholder 2"/>
+          <p:cNvSpPr>
+            <a:spLocks noGrp="1"/>
+          </p:cNvSpPr>
+          <p:nvPr>
+            <p:ph idx="1"/>
+          </p:nvPr>
+        </p:nvSpPr>
+        <p:spPr/>
+        <p:txBody>
+          <a:bodyPr/>
+          <a:lstStyle/>
           <a:p>
             <a:pPr lvl="0" indent="0" marL="0">
               <a:buNone/>
             </a:pPr>
             <a:r>
               <a:rPr/>
-              <a:t>Under the supervision of Dr. Preeti Bansal, Department of IT, NSUT</a:t>
+              <a:t>[1] Cantone, Marrocco, Bria, “On the cross-dataset generalization of machine learning for network intrusion detection,” </a:t>
+            </a:r>
+            <a:r>
+              <a:rPr i="1"/>
+              <a:t>IEEE Access</a:t>
+            </a:r>
+            <a:r>
+              <a:rPr/>
+              <a:t>, 2024.</a:t>
+            </a:r>
+          </a:p>
+          <a:p>
+            <a:pPr lvl="0" indent="0" marL="0">
+              <a:buNone/>
+            </a:pPr>
+            <a:r>
+              <a:rPr/>
+              <a:t>[2] Hossain et al., “Assessing generalisation capability of machine learning models for intrusion detection,” arXiv:2605.04407, 2026.</a:t>
+            </a:r>
+          </a:p>
+          <a:p>
+            <a:pPr lvl="0" indent="0" marL="0">
+              <a:buNone/>
+            </a:pPr>
+            <a:r>
+              <a:rPr/>
+              <a:t>[3] Hakim, Uddin, Anis, “Cross-domain generalization failure in lightweight intrusion detection models for IIoT networks,” arXiv:2607.00553, 2026.</a:t>
+            </a:r>
+          </a:p>
+          <a:p>
+            <a:pPr lvl="0" indent="0" marL="0">
+              <a:buNone/>
+            </a:pPr>
+            <a:r>
+              <a:rPr/>
+              <a:t>[4] Butt, Hotho, Schlör, “Evaluating tabular representation learning for network intrusion detection,” </a:t>
+            </a:r>
+            <a:r>
+              <a:rPr i="1"/>
+              <a:t>IEEE CSR</a:t>
+            </a:r>
+            <a:r>
+              <a:rPr/>
+              <a:t>, 2026.</a:t>
+            </a:r>
+          </a:p>
+          <a:p>
+            <a:pPr lvl="0" indent="0" marL="0">
+              <a:buNone/>
+            </a:pPr>
+            <a:r>
+              <a:rPr/>
+              <a:t>[5] Sharafaldin, Lashkari, Ghorbani, “Toward generating a new intrusion detection dataset…” (CIC-IDS-2017), </a:t>
+            </a:r>
+            <a:r>
+              <a:rPr i="1"/>
+              <a:t>ICISSP</a:t>
+            </a:r>
+            <a:r>
+              <a:rPr/>
+              <a:t>, 2018.</a:t>
+            </a:r>
+          </a:p>
+          <a:p>
+            <a:pPr lvl="0" indent="0" marL="0">
+              <a:buNone/>
+            </a:pPr>
+            <a:r>
+              <a:rPr/>
+              <a:t>[6] Moustafa, Slay, “UNSW-NB15: a comprehensive data set…”, </a:t>
+            </a:r>
+            <a:r>
+              <a:rPr i="1"/>
+              <a:t>MilCIS</a:t>
+            </a:r>
+            <a:r>
+              <a:rPr/>
+              <a:t>, 2015.</a:t>
+            </a:r>
+          </a:p>
+          <a:p>
+            <a:pPr lvl="0" indent="0" marL="0">
+              <a:buNone/>
+            </a:pPr>
+            <a:r>
+              <a:rPr/>
+              <a:t>[7] Moustafa, “Network TON_IoT datasets,” </a:t>
+            </a:r>
+            <a:r>
+              <a:rPr i="1"/>
+              <a:t>Sustainable Cities and Society</a:t>
+            </a:r>
+            <a:r>
+              <a:rPr/>
+              <a:t>, 2021.</a:t>
+            </a:r>
+          </a:p>
+          <a:p>
+            <a:pPr lvl="0" indent="0" marL="0">
+              <a:buNone/>
+            </a:pPr>
+            <a:r>
+              <a:rPr/>
+              <a:t>[8]–[12] Fatima &amp; Ali (2022); Suman et al. (2019); Li (2026); Mojtahedi et al. (2022); Yang et al. (2026).</a:t>
+            </a:r>
+          </a:p>
+          <a:p>
+            <a:pPr lvl="0" indent="0" marL="0">
+              <a:buNone/>
+            </a:pPr>
+            <a:r>
+              <a:rPr/>
+              <a:t>[13] Layeghy, Baktashmotlagh, Portmann, “DI-NIDS,” </a:t>
+            </a:r>
+            <a:r>
+              <a:rPr i="1"/>
+              <a:t>Knowledge-Based Systems</a:t>
+            </a:r>
+            <a:r>
+              <a:rPr/>
+              <a:t>, 2023.</a:t>
+            </a:r>
+          </a:p>
+          <a:p>
+            <a:pPr lvl="0" indent="0" marL="0">
+              <a:buNone/>
+            </a:pPr>
+            <a:r>
+              <a:rPr/>
+              <a:t>[14] Ring et al., “A survey of network-based intrusion detection data sets,” </a:t>
+            </a:r>
+            <a:r>
+              <a:rPr i="1"/>
+              <a:t>Computers &amp; Security</a:t>
+            </a:r>
+            <a:r>
+              <a:rPr/>
+              <a:t>, 2019.</a:t>
+            </a:r>
+          </a:p>
+          <a:p>
+            <a:pPr lvl="0" indent="0" marL="0">
+              <a:buNone/>
+            </a:pPr>
+            <a:r>
+              <a:rPr/>
+              <a:t>[15] Vitorino et al., “An adversarial robustness benchmark for enterprise NIDS,” </a:t>
+            </a:r>
+            <a:r>
+              <a:rPr i="1"/>
+              <a:t>FPS</a:t>
+            </a:r>
+            <a:r>
+              <a:rPr/>
+              <a:t>, 2023.</a:t>
             </a:r>
           </a:p>
         </p:txBody>

</xml_diff>